<commit_message>
Deploy latest hackathon certificate template modifications to backend
</commit_message>
<xml_diff>
--- a/CERTIFICATE_TEMPLATE - hackathon.pptx
+++ b/CERTIFICATE_TEMPLATE - hackathon.pptx
@@ -4566,7 +4566,7 @@
         </p:nvSpPr>
         <p:spPr>
           <a:xfrm>
-            <a:off x="4801333" y="1535897"/>
+            <a:off x="4801333" y="1510497"/>
             <a:ext cx="1026566" cy="196139"/>
           </a:xfrm>
           <a:prstGeom prst="rect">
@@ -5127,7 +5127,7 @@
         </p:nvSpPr>
         <p:spPr>
           <a:xfrm>
-            <a:off x="4726682" y="3039235"/>
+            <a:off x="4726682" y="3022090"/>
             <a:ext cx="1122415" cy="171548"/>
           </a:xfrm>
           <a:prstGeom prst="rect">

</xml_diff>